<commit_message>
Publish Setting Up Your Board after building Prop Loft's board by hand
Prop Loft's session-17 state is published (SKIP_BOARD=1 in seed.sh leaves
the board to be built by hand), and walking the page against today's
GitHub UI turned up gaps:

- Section 5's list broke on Canvas: nested content was indented 3 spaces,
  and Python-Markdown needs 4.
- Workflows is a button; which workflows start on varies; the board holds
  issues only (auto-add is:issue is:open, item added -> Backlog).
- Board views use View -> Swimlanes; views must be saved.
- The Size field is created from a table (+ -> Add field -> Create a
  project field, not the org-wide issue fields), with Show hierarchy off
  so tasks aren't hidden under their epics. Session 18 demos it live.

The three screenshots replace the placeholders and the page is published.
Session 17 and 18 outlines, decks, seed.sh, and the checklist match.

Co-Authored-By: Claude Opus 5.5 <noreply@anthropic.com>
</commit_message>
<xml_diff>
--- a/canvas_material/lectures/powerpoint/Session17-DesignToWork.pptx
+++ b/canvas_material/lectures/powerpoint/Session17-DesignToWork.pptx
@@ -1315,7 +1315,7 @@
           <a:p>
             <a:r>
               <a:rPr lang="en-US" dirty="0"/>
-              <a:t>Demo it live on Prop Loft or a scratch org, about four minutes, then leave this up during the workshop. Step 1 imports existing issues because auto-add only catches new ones, and free organizations get one auto-add workflow. Step 4 is the trap: projects start private, so a stranger or the auditor sees nothing. Say it twice. The page has every click; students don't need to copy this down.</a:t>
+              <a:t>Demo it live on Prop Loft or a scratch org, about four minutes, then leave this up during the workshop. Step 1 imports existing issues because auto-add only catches new ones, and free organizations get one auto-add workflow. Step 3: the board holds issues only; a PR shows on the card of the issue it closes. Which workflows start out on varies, so check each one. Step 5: on a board the setting is called Swimlanes, and an unsaved view shows a dot on its tab and reverts. Step 4 is the trap: projects start private, so a stranger or the auditor sees nothing. Say it twice. The page has every click; students don't need to copy this down.</a:t>
             </a:r>
             <a:endParaRPr lang="en-US" dirty="0"/>
           </a:p>
@@ -12531,7 +12531,7 @@
                 <a:ea typeface="Calibri" pitchFamily="34" charset="-122"/>
                 <a:cs typeface="Calibri" pitchFamily="34" charset="-120"/>
               </a:rPr>
-              <a:t>Turn on auto-add</a:t>
+              <a:t>Set up the workflows</a:t>
             </a:r>
             <a:endParaRPr lang="en-US" sz="1700" dirty="0"/>
           </a:p>
@@ -12570,7 +12570,7 @@
                 <a:ea typeface="Calibri" pitchFamily="34" charset="-122"/>
                 <a:cs typeface="Calibri" pitchFamily="34" charset="-120"/>
               </a:rPr>
-              <a:t>⋯ → Workflows → Auto-add: is:issue,pr is:open. Closed and merged → Done is already on.</a:t>
+              <a:t>Workflows: auto-add is:issue is:open; new items → Backlog; closed and merged → Done.</a:t>
             </a:r>
             <a:endParaRPr lang="en-US" sz="1550" dirty="0"/>
           </a:p>
@@ -12902,7 +12902,7 @@
                 <a:ea typeface="Calibri" pitchFamily="34" charset="-122"/>
                 <a:cs typeface="Calibri" pitchFamily="34" charset="-120"/>
               </a:rPr>
-              <a:t>Grouped by milestone (what's left?) and by parent issue (how's each epic?).</a:t>
+              <a:t>Swimlanes by milestone (what's left?) and by parent issue (how's each epic?). Save each.</a:t>
             </a:r>
             <a:endParaRPr lang="en-US" sz="1550" dirty="0"/>
           </a:p>

</xml_diff>